<commit_message>
feat: Aggiunta seconda verifica batchv2 e riordino
</commit_message>
<xml_diff>
--- a/notes/second_part_pipeline_topologica/doc_scripts_1.0/pipeline_01_06.pptx
+++ b/notes/second_part_pipeline_topologica/doc_scripts_1.0/pipeline_01_06.pptx
@@ -22723,7 +22723,7 @@
         <p:spPr>
           <a:xfrm>
             <a:off x="5266944" y="1874519"/>
-            <a:ext cx="5806440" cy="1828800"/>
+            <a:ext cx="5479449" cy="1498872"/>
           </a:xfrm>
           <a:prstGeom prst="rect">
             <a:avLst/>
@@ -22747,7 +22747,32 @@
               </a:defRPr>
             </a:pPr>
             <a:r>
-              <a:t>Verde = componente riconosciuto dalla pipeline.</a:t>
+              <a:rPr dirty="0"/>
+              <a:t>Verde = </a:t>
+            </a:r>
+            <a:r>
+              <a:rPr dirty="0" err="1"/>
+              <a:t>componente</a:t>
+            </a:r>
+            <a:r>
+              <a:rPr dirty="0"/>
+              <a:t> </a:t>
+            </a:r>
+            <a:r>
+              <a:rPr dirty="0" err="1"/>
+              <a:t>riconosciuto</a:t>
+            </a:r>
+            <a:r>
+              <a:rPr dirty="0"/>
+              <a:t> </a:t>
+            </a:r>
+            <a:r>
+              <a:rPr dirty="0" err="1"/>
+              <a:t>dalla</a:t>
+            </a:r>
+            <a:r>
+              <a:rPr dirty="0"/>
+              <a:t> pipeline.</a:t>
             </a:r>
           </a:p>
           <a:p>
@@ -22762,7 +22787,56 @@
               </a:defRPr>
             </a:pPr>
             <a:r>
-              <a:t>Giallo = net, cioè gruppo di terminali collegati dallo stesso filo.</a:t>
+              <a:rPr dirty="0"/>
+              <a:t>Giallo = net, </a:t>
+            </a:r>
+            <a:r>
+              <a:rPr dirty="0" err="1"/>
+              <a:t>cioè</a:t>
+            </a:r>
+            <a:r>
+              <a:rPr dirty="0"/>
+              <a:t> </a:t>
+            </a:r>
+            <a:r>
+              <a:rPr dirty="0" err="1"/>
+              <a:t>gruppo</a:t>
+            </a:r>
+            <a:r>
+              <a:rPr dirty="0"/>
+              <a:t> di </a:t>
+            </a:r>
+            <a:r>
+              <a:rPr dirty="0" err="1"/>
+              <a:t>terminali</a:t>
+            </a:r>
+            <a:r>
+              <a:rPr dirty="0"/>
+              <a:t> </a:t>
+            </a:r>
+            <a:r>
+              <a:rPr dirty="0" err="1"/>
+              <a:t>collegati</a:t>
+            </a:r>
+            <a:r>
+              <a:rPr dirty="0"/>
+              <a:t> </a:t>
+            </a:r>
+            <a:r>
+              <a:rPr dirty="0" err="1"/>
+              <a:t>dallo</a:t>
+            </a:r>
+            <a:r>
+              <a:rPr dirty="0"/>
+              <a:t> </a:t>
+            </a:r>
+            <a:r>
+              <a:rPr dirty="0" err="1"/>
+              <a:t>stesso</a:t>
+            </a:r>
+            <a:r>
+              <a:rPr dirty="0"/>
+              <a:t> filo.</a:t>
             </a:r>
           </a:p>
           <a:p>
@@ -22777,8 +22851,50 @@
               </a:defRPr>
             </a:pPr>
             <a:r>
-              <a:t>Una linea componente → net significa che almeno un terminale del componente appartiene a quella net.</a:t>
-            </a:r>
+              <a:rPr dirty="0"/>
+              <a:t>Una </a:t>
+            </a:r>
+            <a:r>
+              <a:rPr dirty="0" err="1"/>
+              <a:t>linea</a:t>
+            </a:r>
+            <a:r>
+              <a:rPr dirty="0"/>
+              <a:t> </a:t>
+            </a:r>
+            <a:r>
+              <a:rPr dirty="0" err="1"/>
+              <a:t>componente</a:t>
+            </a:r>
+            <a:r>
+              <a:rPr dirty="0"/>
+              <a:t> → net </a:t>
+            </a:r>
+            <a:r>
+              <a:rPr dirty="0" err="1"/>
+              <a:t>significa</a:t>
+            </a:r>
+            <a:r>
+              <a:rPr dirty="0"/>
+              <a:t> </a:t>
+            </a:r>
+            <a:r>
+              <a:rPr dirty="0" err="1"/>
+              <a:t>che</a:t>
+            </a:r>
+            <a:r>
+              <a:rPr dirty="0"/>
+              <a:t> </a:t>
+            </a:r>
+            <a:r>
+              <a:rPr dirty="0" err="1"/>
+              <a:t>almeno</a:t>
+            </a:r>
+            <a:r>
+              <a:rPr dirty="0"/>
+              <a:t> un </a:t>
+            </a:r>
+            <a:endParaRPr lang="it-IT" dirty="0"/>
           </a:p>
           <a:p>
             <a:pPr>
@@ -22792,7 +22908,108 @@
               </a:defRPr>
             </a:pPr>
             <a:r>
-              <a:t>I colori degli archi servono solo a distinguere visivamente i gruppi.</a:t>
+              <a:rPr dirty="0" err="1"/>
+              <a:t>terminale</a:t>
+            </a:r>
+            <a:r>
+              <a:rPr dirty="0"/>
+              <a:t> del </a:t>
+            </a:r>
+            <a:r>
+              <a:rPr dirty="0" err="1"/>
+              <a:t>componente</a:t>
+            </a:r>
+            <a:r>
+              <a:rPr dirty="0"/>
+              <a:t> </a:t>
+            </a:r>
+            <a:r>
+              <a:rPr dirty="0" err="1"/>
+              <a:t>appartiene</a:t>
+            </a:r>
+            <a:r>
+              <a:rPr dirty="0"/>
+              <a:t> a </a:t>
+            </a:r>
+            <a:r>
+              <a:rPr dirty="0" err="1"/>
+              <a:t>quella</a:t>
+            </a:r>
+            <a:r>
+              <a:rPr dirty="0"/>
+              <a:t> net.</a:t>
+            </a:r>
+          </a:p>
+          <a:p>
+            <a:pPr>
+              <a:spcAft>
+                <a:spcPts val="600"/>
+              </a:spcAft>
+              <a:defRPr sz="1500">
+                <a:solidFill>
+                  <a:srgbClr val="0F172A"/>
+                </a:solidFill>
+              </a:defRPr>
+            </a:pPr>
+            <a:r>
+              <a:rPr dirty="0"/>
+              <a:t>I </a:t>
+            </a:r>
+            <a:r>
+              <a:rPr dirty="0" err="1"/>
+              <a:t>colori</a:t>
+            </a:r>
+            <a:r>
+              <a:rPr dirty="0"/>
+              <a:t> degli </a:t>
+            </a:r>
+            <a:r>
+              <a:rPr dirty="0" err="1"/>
+              <a:t>archi</a:t>
+            </a:r>
+            <a:r>
+              <a:rPr dirty="0"/>
+              <a:t> </a:t>
+            </a:r>
+            <a:r>
+              <a:rPr dirty="0" err="1"/>
+              <a:t>servono</a:t>
+            </a:r>
+            <a:r>
+              <a:rPr dirty="0"/>
+              <a:t> solo a </a:t>
+            </a:r>
+            <a:r>
+              <a:rPr dirty="0" err="1"/>
+              <a:t>distinguere</a:t>
+            </a:r>
+            <a:r>
+              <a:rPr dirty="0"/>
+              <a:t> </a:t>
+            </a:r>
+            <a:r>
+              <a:rPr dirty="0" err="1"/>
+              <a:t>visivamente</a:t>
+            </a:r>
+            <a:r>
+              <a:rPr dirty="0"/>
+              <a:t> </a:t>
+            </a:r>
+            <a:r>
+              <a:rPr dirty="0" err="1"/>
+              <a:t>i</a:t>
+            </a:r>
+            <a:r>
+              <a:rPr dirty="0"/>
+              <a:t> </a:t>
+            </a:r>
+            <a:r>
+              <a:rPr dirty="0" err="1"/>
+              <a:t>gruppi</a:t>
+            </a:r>
+            <a:r>
+              <a:rPr dirty="0"/>
+              <a:t>.</a:t>
             </a:r>
           </a:p>
         </p:txBody>
@@ -22886,7 +23103,7 @@
         <p:spPr>
           <a:xfrm>
             <a:off x="5449824" y="4736592"/>
-            <a:ext cx="5074920" cy="420624"/>
+            <a:ext cx="4663969" cy="456535"/>
           </a:xfrm>
           <a:prstGeom prst="rect">
             <a:avLst/>
@@ -22910,7 +23127,89 @@
               </a:defRPr>
             </a:pPr>
             <a:r>
-              <a:t>Riduce le clique dense del graph 05: invece di molte connessioni terminale-terminale, mostra un solo nodo elettrico condiviso.</a:t>
+              <a:rPr dirty="0" err="1"/>
+              <a:t>Riduce</a:t>
+            </a:r>
+            <a:r>
+              <a:rPr dirty="0"/>
+              <a:t> le clique dense del graph 05: </a:t>
+            </a:r>
+            <a:r>
+              <a:rPr dirty="0" err="1"/>
+              <a:t>invece</a:t>
+            </a:r>
+            <a:r>
+              <a:rPr dirty="0"/>
+              <a:t> di </a:t>
+            </a:r>
+            <a:r>
+              <a:rPr dirty="0" err="1"/>
+              <a:t>molte</a:t>
+            </a:r>
+            <a:r>
+              <a:rPr dirty="0"/>
+              <a:t> </a:t>
+            </a:r>
+            <a:r>
+              <a:rPr dirty="0" err="1"/>
+              <a:t>connessioni</a:t>
+            </a:r>
+            <a:r>
+              <a:rPr dirty="0"/>
+              <a:t> </a:t>
+            </a:r>
+            <a:endParaRPr lang="it-IT" dirty="0"/>
+          </a:p>
+          <a:p>
+            <a:pPr>
+              <a:spcAft>
+                <a:spcPts val="200"/>
+              </a:spcAft>
+              <a:defRPr sz="1280">
+                <a:solidFill>
+                  <a:srgbClr val="0F172A"/>
+                </a:solidFill>
+              </a:defRPr>
+            </a:pPr>
+            <a:r>
+              <a:rPr dirty="0" err="1"/>
+              <a:t>terminale-terminale</a:t>
+            </a:r>
+            <a:r>
+              <a:rPr dirty="0"/>
+              <a:t>, </a:t>
+            </a:r>
+            <a:r>
+              <a:rPr dirty="0" err="1"/>
+              <a:t>mostra</a:t>
+            </a:r>
+            <a:r>
+              <a:rPr dirty="0"/>
+              <a:t> un solo </a:t>
+            </a:r>
+            <a:r>
+              <a:rPr dirty="0" err="1"/>
+              <a:t>nodo</a:t>
+            </a:r>
+            <a:r>
+              <a:rPr dirty="0"/>
+              <a:t> </a:t>
+            </a:r>
+            <a:r>
+              <a:rPr dirty="0" err="1"/>
+              <a:t>elettrico</a:t>
+            </a:r>
+            <a:r>
+              <a:rPr dirty="0"/>
+              <a:t> </a:t>
+            </a:r>
+            <a:r>
+              <a:rPr dirty="0" err="1"/>
+              <a:t>condiviso</a:t>
+            </a:r>
+            <a:r>
+              <a:rPr dirty="0"/>
+              <a:t>.</a:t>
             </a:r>
           </a:p>
         </p:txBody>
@@ -25113,7 +25412,7 @@
         <p:spPr>
           <a:xfrm>
             <a:off x="950976" y="4736592"/>
-            <a:ext cx="3337560" cy="731520"/>
+            <a:ext cx="3519746" cy="627864"/>
           </a:xfrm>
           <a:prstGeom prst="rect">
             <a:avLst/>
@@ -25127,13 +25426,254 @@
           <a:lstStyle/>
           <a:p>
             <a:r>
-              <a:rPr sz="1280" b="0">
+              <a:rPr sz="1280" b="0" dirty="0">
                 <a:solidFill>
                   <a:srgbClr val="475569"/>
                 </a:solidFill>
                 <a:latin typeface="Aptos"/>
               </a:rPr>
-              <a:t>Questa vista è più densa, ma conserva i terminali singoli e quindi aiuta a individuare errori di matching o terminali isolati.</a:t>
+              <a:t>Questa vista è </a:t>
+            </a:r>
+            <a:r>
+              <a:rPr sz="1280" b="0" dirty="0" err="1">
+                <a:solidFill>
+                  <a:srgbClr val="475569"/>
+                </a:solidFill>
+                <a:latin typeface="Aptos"/>
+              </a:rPr>
+              <a:t>più</a:t>
+            </a:r>
+            <a:r>
+              <a:rPr sz="1280" b="0" dirty="0">
+                <a:solidFill>
+                  <a:srgbClr val="475569"/>
+                </a:solidFill>
+                <a:latin typeface="Aptos"/>
+              </a:rPr>
+              <a:t> </a:t>
+            </a:r>
+            <a:r>
+              <a:rPr sz="1280" b="0" dirty="0" err="1">
+                <a:solidFill>
+                  <a:srgbClr val="475569"/>
+                </a:solidFill>
+                <a:latin typeface="Aptos"/>
+              </a:rPr>
+              <a:t>densa</a:t>
+            </a:r>
+            <a:r>
+              <a:rPr sz="1280" b="0" dirty="0">
+                <a:solidFill>
+                  <a:srgbClr val="475569"/>
+                </a:solidFill>
+                <a:latin typeface="Aptos"/>
+              </a:rPr>
+              <a:t>, ma </a:t>
+            </a:r>
+            <a:r>
+              <a:rPr sz="1280" b="0" dirty="0" err="1">
+                <a:solidFill>
+                  <a:srgbClr val="475569"/>
+                </a:solidFill>
+                <a:latin typeface="Aptos"/>
+              </a:rPr>
+              <a:t>conserva</a:t>
+            </a:r>
+            <a:r>
+              <a:rPr sz="1280" b="0" dirty="0">
+                <a:solidFill>
+                  <a:srgbClr val="475569"/>
+                </a:solidFill>
+                <a:latin typeface="Aptos"/>
+              </a:rPr>
+              <a:t> </a:t>
+            </a:r>
+            <a:r>
+              <a:rPr sz="1280" b="0" dirty="0" err="1">
+                <a:solidFill>
+                  <a:srgbClr val="475569"/>
+                </a:solidFill>
+                <a:latin typeface="Aptos"/>
+              </a:rPr>
+              <a:t>i</a:t>
+            </a:r>
+            <a:r>
+              <a:rPr sz="1280" b="0" dirty="0">
+                <a:solidFill>
+                  <a:srgbClr val="475569"/>
+                </a:solidFill>
+                <a:latin typeface="Aptos"/>
+              </a:rPr>
+              <a:t> </a:t>
+            </a:r>
+            <a:r>
+              <a:rPr sz="1280" b="0" dirty="0" err="1">
+                <a:solidFill>
+                  <a:srgbClr val="475569"/>
+                </a:solidFill>
+                <a:latin typeface="Aptos"/>
+              </a:rPr>
+              <a:t>terminali</a:t>
+            </a:r>
+            <a:r>
+              <a:rPr sz="1280" b="0" dirty="0">
+                <a:solidFill>
+                  <a:srgbClr val="475569"/>
+                </a:solidFill>
+                <a:latin typeface="Aptos"/>
+              </a:rPr>
+              <a:t> </a:t>
+            </a:r>
+            <a:endParaRPr lang="it-IT" sz="1280" b="0" dirty="0">
+              <a:solidFill>
+                <a:srgbClr val="475569"/>
+              </a:solidFill>
+              <a:latin typeface="Aptos"/>
+            </a:endParaRPr>
+          </a:p>
+          <a:p>
+            <a:r>
+              <a:rPr sz="1280" b="0" dirty="0" err="1">
+                <a:solidFill>
+                  <a:srgbClr val="475569"/>
+                </a:solidFill>
+                <a:latin typeface="Aptos"/>
+              </a:rPr>
+              <a:t>singoli</a:t>
+            </a:r>
+            <a:r>
+              <a:rPr sz="1280" b="0" dirty="0">
+                <a:solidFill>
+                  <a:srgbClr val="475569"/>
+                </a:solidFill>
+                <a:latin typeface="Aptos"/>
+              </a:rPr>
+              <a:t> e </a:t>
+            </a:r>
+            <a:r>
+              <a:rPr sz="1280" b="0" dirty="0" err="1">
+                <a:solidFill>
+                  <a:srgbClr val="475569"/>
+                </a:solidFill>
+                <a:latin typeface="Aptos"/>
+              </a:rPr>
+              <a:t>quindi</a:t>
+            </a:r>
+            <a:r>
+              <a:rPr sz="1280" b="0" dirty="0">
+                <a:solidFill>
+                  <a:srgbClr val="475569"/>
+                </a:solidFill>
+                <a:latin typeface="Aptos"/>
+              </a:rPr>
+              <a:t> </a:t>
+            </a:r>
+            <a:r>
+              <a:rPr sz="1280" b="0" dirty="0" err="1">
+                <a:solidFill>
+                  <a:srgbClr val="475569"/>
+                </a:solidFill>
+                <a:latin typeface="Aptos"/>
+              </a:rPr>
+              <a:t>aiuta</a:t>
+            </a:r>
+            <a:r>
+              <a:rPr sz="1280" b="0" dirty="0">
+                <a:solidFill>
+                  <a:srgbClr val="475569"/>
+                </a:solidFill>
+                <a:latin typeface="Aptos"/>
+              </a:rPr>
+              <a:t> a </a:t>
+            </a:r>
+            <a:r>
+              <a:rPr sz="1280" b="0" dirty="0" err="1">
+                <a:solidFill>
+                  <a:srgbClr val="475569"/>
+                </a:solidFill>
+                <a:latin typeface="Aptos"/>
+              </a:rPr>
+              <a:t>individuare</a:t>
+            </a:r>
+            <a:r>
+              <a:rPr sz="1280" b="0" dirty="0">
+                <a:solidFill>
+                  <a:srgbClr val="475569"/>
+                </a:solidFill>
+                <a:latin typeface="Aptos"/>
+              </a:rPr>
+              <a:t> </a:t>
+            </a:r>
+            <a:r>
+              <a:rPr sz="1280" b="0" dirty="0" err="1">
+                <a:solidFill>
+                  <a:srgbClr val="475569"/>
+                </a:solidFill>
+                <a:latin typeface="Aptos"/>
+              </a:rPr>
+              <a:t>errori</a:t>
+            </a:r>
+            <a:r>
+              <a:rPr sz="1280" b="0" dirty="0">
+                <a:solidFill>
+                  <a:srgbClr val="475569"/>
+                </a:solidFill>
+                <a:latin typeface="Aptos"/>
+              </a:rPr>
+              <a:t> </a:t>
+            </a:r>
+            <a:endParaRPr lang="it-IT" sz="1280" b="0" dirty="0">
+              <a:solidFill>
+                <a:srgbClr val="475569"/>
+              </a:solidFill>
+              <a:latin typeface="Aptos"/>
+            </a:endParaRPr>
+          </a:p>
+          <a:p>
+            <a:r>
+              <a:rPr sz="1280" b="0" dirty="0">
+                <a:solidFill>
+                  <a:srgbClr val="475569"/>
+                </a:solidFill>
+                <a:latin typeface="Aptos"/>
+              </a:rPr>
+              <a:t>di matching o </a:t>
+            </a:r>
+            <a:r>
+              <a:rPr sz="1280" b="0" dirty="0" err="1">
+                <a:solidFill>
+                  <a:srgbClr val="475569"/>
+                </a:solidFill>
+                <a:latin typeface="Aptos"/>
+              </a:rPr>
+              <a:t>terminali</a:t>
+            </a:r>
+            <a:r>
+              <a:rPr sz="1280" b="0" dirty="0">
+                <a:solidFill>
+                  <a:srgbClr val="475569"/>
+                </a:solidFill>
+                <a:latin typeface="Aptos"/>
+              </a:rPr>
+              <a:t> </a:t>
+            </a:r>
+            <a:r>
+              <a:rPr sz="1280" b="0" dirty="0" err="1">
+                <a:solidFill>
+                  <a:srgbClr val="475569"/>
+                </a:solidFill>
+                <a:latin typeface="Aptos"/>
+              </a:rPr>
+              <a:t>isolati</a:t>
+            </a:r>
+            <a:r>
+              <a:rPr sz="1280" b="0" dirty="0">
+                <a:solidFill>
+                  <a:srgbClr val="475569"/>
+                </a:solidFill>
+                <a:latin typeface="Aptos"/>
+              </a:rPr>
+              <a:t>.</a:t>
             </a:r>
           </a:p>
         </p:txBody>
@@ -25616,7 +26156,7 @@
         <p:spPr>
           <a:xfrm>
             <a:off x="6199632" y="1901952"/>
-            <a:ext cx="4937760" cy="2148840"/>
+            <a:ext cx="6048964" cy="1309076"/>
           </a:xfrm>
           <a:prstGeom prst="rect">
             <a:avLst/>
@@ -25640,7 +26180,56 @@
               </a:defRPr>
             </a:pPr>
             <a:r>
-              <a:t>`extract_graph_structures`: ricostruisce componenti, terminali e gruppi connessi.</a:t>
+              <a:rPr dirty="0"/>
+              <a:t>`</a:t>
+            </a:r>
+            <a:r>
+              <a:rPr dirty="0" err="1"/>
+              <a:t>extract_graph_structures</a:t>
+            </a:r>
+            <a:r>
+              <a:rPr dirty="0"/>
+              <a:t>`: </a:t>
+            </a:r>
+            <a:r>
+              <a:rPr dirty="0" err="1"/>
+              <a:t>ricostruisce</a:t>
+            </a:r>
+            <a:r>
+              <a:rPr dirty="0"/>
+              <a:t> </a:t>
+            </a:r>
+            <a:r>
+              <a:rPr dirty="0" err="1"/>
+              <a:t>componenti</a:t>
+            </a:r>
+            <a:r>
+              <a:rPr dirty="0"/>
+              <a:t>, </a:t>
+            </a:r>
+            <a:r>
+              <a:rPr dirty="0" err="1"/>
+              <a:t>terminali</a:t>
+            </a:r>
+            <a:r>
+              <a:rPr dirty="0"/>
+              <a:t> e </a:t>
+            </a:r>
+            <a:r>
+              <a:rPr dirty="0" err="1"/>
+              <a:t>gruppi</a:t>
+            </a:r>
+            <a:r>
+              <a:rPr dirty="0"/>
+              <a:t> </a:t>
+            </a:r>
+            <a:r>
+              <a:rPr dirty="0" err="1"/>
+              <a:t>connessi</a:t>
+            </a:r>
+            <a:r>
+              <a:rPr dirty="0"/>
+              <a:t>.</a:t>
             </a:r>
           </a:p>
           <a:p>
@@ -25655,8 +26244,34 @@
               </a:defRPr>
             </a:pPr>
             <a:r>
-              <a:t>`build_visual_model`: crea la vista completa root → classi → componenti → terminali → net.</a:t>
-            </a:r>
+              <a:rPr dirty="0"/>
+              <a:t>`</a:t>
+            </a:r>
+            <a:r>
+              <a:rPr dirty="0" err="1"/>
+              <a:t>build_visual_model</a:t>
+            </a:r>
+            <a:r>
+              <a:rPr dirty="0"/>
+              <a:t>`: </a:t>
+            </a:r>
+            <a:r>
+              <a:rPr dirty="0" err="1"/>
+              <a:t>crea</a:t>
+            </a:r>
+            <a:r>
+              <a:rPr dirty="0"/>
+              <a:t> la vista completa root → </a:t>
+            </a:r>
+            <a:r>
+              <a:rPr dirty="0" err="1"/>
+              <a:t>classi</a:t>
+            </a:r>
+            <a:r>
+              <a:rPr dirty="0"/>
+              <a:t> → </a:t>
+            </a:r>
+            <a:endParaRPr lang="it-IT" dirty="0"/>
           </a:p>
           <a:p>
             <a:pPr>
@@ -25670,7 +26285,20 @@
               </a:defRPr>
             </a:pPr>
             <a:r>
-              <a:t>`build_compact_visual_model`: crea la vista componenti e net.</a:t>
+              <a:rPr dirty="0" err="1"/>
+              <a:t>componenti</a:t>
+            </a:r>
+            <a:r>
+              <a:rPr dirty="0"/>
+              <a:t> → </a:t>
+            </a:r>
+            <a:r>
+              <a:rPr dirty="0" err="1"/>
+              <a:t>terminali</a:t>
+            </a:r>
+            <a:r>
+              <a:rPr dirty="0"/>
+              <a:t> → net.</a:t>
             </a:r>
           </a:p>
           <a:p>
@@ -25685,7 +26313,104 @@
               </a:defRPr>
             </a:pPr>
             <a:r>
-              <a:t>`render_png` e funzioni HTML: salvano immagini statiche e pagine interattive.</a:t>
+              <a:rPr dirty="0"/>
+              <a:t>`</a:t>
+            </a:r>
+            <a:r>
+              <a:rPr dirty="0" err="1"/>
+              <a:t>build_compact_visual_model</a:t>
+            </a:r>
+            <a:r>
+              <a:rPr dirty="0"/>
+              <a:t>`: </a:t>
+            </a:r>
+            <a:r>
+              <a:rPr dirty="0" err="1"/>
+              <a:t>crea</a:t>
+            </a:r>
+            <a:r>
+              <a:rPr dirty="0"/>
+              <a:t> la vista </a:t>
+            </a:r>
+            <a:r>
+              <a:rPr dirty="0" err="1"/>
+              <a:t>componenti</a:t>
+            </a:r>
+            <a:r>
+              <a:rPr dirty="0"/>
+              <a:t> e net.</a:t>
+            </a:r>
+          </a:p>
+          <a:p>
+            <a:pPr>
+              <a:spcAft>
+                <a:spcPts val="500"/>
+              </a:spcAft>
+              <a:defRPr sz="1320">
+                <a:solidFill>
+                  <a:srgbClr val="0F172A"/>
+                </a:solidFill>
+              </a:defRPr>
+            </a:pPr>
+            <a:r>
+              <a:rPr dirty="0"/>
+              <a:t>`</a:t>
+            </a:r>
+            <a:r>
+              <a:rPr dirty="0" err="1"/>
+              <a:t>render_png</a:t>
+            </a:r>
+            <a:r>
+              <a:rPr dirty="0"/>
+              <a:t>` e </a:t>
+            </a:r>
+            <a:r>
+              <a:rPr dirty="0" err="1"/>
+              <a:t>funzioni</a:t>
+            </a:r>
+            <a:r>
+              <a:rPr dirty="0"/>
+              <a:t> HTML: </a:t>
+            </a:r>
+            <a:r>
+              <a:rPr dirty="0" err="1"/>
+              <a:t>salvano</a:t>
+            </a:r>
+            <a:r>
+              <a:rPr dirty="0"/>
+              <a:t> </a:t>
+            </a:r>
+            <a:r>
+              <a:rPr dirty="0" err="1"/>
+              <a:t>immagini</a:t>
+            </a:r>
+            <a:r>
+              <a:rPr dirty="0"/>
+              <a:t> </a:t>
+            </a:r>
+            <a:r>
+              <a:rPr dirty="0" err="1"/>
+              <a:t>statiche</a:t>
+            </a:r>
+            <a:r>
+              <a:rPr dirty="0"/>
+              <a:t> e </a:t>
+            </a:r>
+            <a:r>
+              <a:rPr dirty="0" err="1"/>
+              <a:t>pagine</a:t>
+            </a:r>
+            <a:r>
+              <a:rPr dirty="0"/>
+              <a:t> </a:t>
+            </a:r>
+            <a:r>
+              <a:rPr dirty="0" err="1"/>
+              <a:t>interattive</a:t>
+            </a:r>
+            <a:r>
+              <a:rPr dirty="0"/>
+              <a:t>.</a:t>
             </a:r>
           </a:p>
         </p:txBody>
@@ -25779,7 +26504,7 @@
         <p:spPr>
           <a:xfrm>
             <a:off x="6400800" y="5230368"/>
-            <a:ext cx="4434840" cy="320040"/>
+            <a:ext cx="4008854" cy="415498"/>
           </a:xfrm>
           <a:prstGeom prst="rect">
             <a:avLst/>
@@ -25793,13 +26518,156 @@
           <a:lstStyle/>
           <a:p>
             <a:r>
-              <a:rPr sz="1230" b="0">
+              <a:rPr sz="1230" b="0" dirty="0" err="1">
                 <a:solidFill>
                   <a:srgbClr val="0F172A"/>
                 </a:solidFill>
                 <a:latin typeface="Aptos"/>
               </a:rPr>
-              <a:t>Permette di mostrare il passaggio da JSON testuale a grafo ispezionabile, separando topologia e visualizzazione.</a:t>
+              <a:t>Permette</a:t>
+            </a:r>
+            <a:r>
+              <a:rPr sz="1230" b="0" dirty="0">
+                <a:solidFill>
+                  <a:srgbClr val="0F172A"/>
+                </a:solidFill>
+                <a:latin typeface="Aptos"/>
+              </a:rPr>
+              <a:t> di </a:t>
+            </a:r>
+            <a:r>
+              <a:rPr sz="1230" b="0" dirty="0" err="1">
+                <a:solidFill>
+                  <a:srgbClr val="0F172A"/>
+                </a:solidFill>
+                <a:latin typeface="Aptos"/>
+              </a:rPr>
+              <a:t>mostrare</a:t>
+            </a:r>
+            <a:r>
+              <a:rPr sz="1230" b="0" dirty="0">
+                <a:solidFill>
+                  <a:srgbClr val="0F172A"/>
+                </a:solidFill>
+                <a:latin typeface="Aptos"/>
+              </a:rPr>
+              <a:t> il passaggio da JSON </a:t>
+            </a:r>
+            <a:r>
+              <a:rPr sz="1230" b="0" dirty="0" err="1">
+                <a:solidFill>
+                  <a:srgbClr val="0F172A"/>
+                </a:solidFill>
+                <a:latin typeface="Aptos"/>
+              </a:rPr>
+              <a:t>testuale</a:t>
+            </a:r>
+            <a:r>
+              <a:rPr sz="1230" b="0" dirty="0">
+                <a:solidFill>
+                  <a:srgbClr val="0F172A"/>
+                </a:solidFill>
+                <a:latin typeface="Aptos"/>
+              </a:rPr>
+              <a:t> a </a:t>
+            </a:r>
+            <a:r>
+              <a:rPr sz="1230" b="0" dirty="0" err="1">
+                <a:solidFill>
+                  <a:srgbClr val="0F172A"/>
+                </a:solidFill>
+                <a:latin typeface="Aptos"/>
+              </a:rPr>
+              <a:t>grafo</a:t>
+            </a:r>
+            <a:r>
+              <a:rPr sz="1230" b="0" dirty="0">
+                <a:solidFill>
+                  <a:srgbClr val="0F172A"/>
+                </a:solidFill>
+                <a:latin typeface="Aptos"/>
+              </a:rPr>
+              <a:t> </a:t>
+            </a:r>
+            <a:endParaRPr lang="it-IT" sz="1230" b="0" dirty="0">
+              <a:solidFill>
+                <a:srgbClr val="0F172A"/>
+              </a:solidFill>
+              <a:latin typeface="Aptos"/>
+            </a:endParaRPr>
+          </a:p>
+          <a:p>
+            <a:r>
+              <a:rPr sz="1230" b="0" dirty="0" err="1">
+                <a:solidFill>
+                  <a:srgbClr val="0F172A"/>
+                </a:solidFill>
+                <a:latin typeface="Aptos"/>
+              </a:rPr>
+              <a:t>ispezionabile</a:t>
+            </a:r>
+            <a:r>
+              <a:rPr sz="1230" b="0" dirty="0">
+                <a:solidFill>
+                  <a:srgbClr val="0F172A"/>
+                </a:solidFill>
+                <a:latin typeface="Aptos"/>
+              </a:rPr>
+              <a:t>, </a:t>
+            </a:r>
+            <a:r>
+              <a:rPr sz="1230" b="0" dirty="0" err="1">
+                <a:solidFill>
+                  <a:srgbClr val="0F172A"/>
+                </a:solidFill>
+                <a:latin typeface="Aptos"/>
+              </a:rPr>
+              <a:t>separando</a:t>
+            </a:r>
+            <a:r>
+              <a:rPr sz="1230" b="0" dirty="0">
+                <a:solidFill>
+                  <a:srgbClr val="0F172A"/>
+                </a:solidFill>
+                <a:latin typeface="Aptos"/>
+              </a:rPr>
+              <a:t> </a:t>
+            </a:r>
+            <a:r>
+              <a:rPr sz="1230" b="0" dirty="0" err="1">
+                <a:solidFill>
+                  <a:srgbClr val="0F172A"/>
+                </a:solidFill>
+                <a:latin typeface="Aptos"/>
+              </a:rPr>
+              <a:t>topologia</a:t>
+            </a:r>
+            <a:r>
+              <a:rPr sz="1230" b="0" dirty="0">
+                <a:solidFill>
+                  <a:srgbClr val="0F172A"/>
+                </a:solidFill>
+                <a:latin typeface="Aptos"/>
+              </a:rPr>
+              <a:t> e </a:t>
+            </a:r>
+            <a:r>
+              <a:rPr sz="1230" b="0" dirty="0" err="1">
+                <a:solidFill>
+                  <a:srgbClr val="0F172A"/>
+                </a:solidFill>
+                <a:latin typeface="Aptos"/>
+              </a:rPr>
+              <a:t>visualizzazione</a:t>
+            </a:r>
+            <a:r>
+              <a:rPr sz="1230" b="0" dirty="0">
+                <a:solidFill>
+                  <a:srgbClr val="0F172A"/>
+                </a:solidFill>
+                <a:latin typeface="Aptos"/>
+              </a:rPr>
+              <a:t>.</a:t>
             </a:r>
           </a:p>
         </p:txBody>
@@ -33237,14 +34105,6 @@
 </file>
 
 <file path=customXml/item1.xml><?xml version="1.0" encoding="utf-8"?>
-<p:properties xmlns:p="http://schemas.microsoft.com/office/2006/metadata/properties" xmlns:xsi="http://www.w3.org/2001/XMLSchema-instance" xmlns:pc="http://schemas.microsoft.com/office/infopath/2007/PartnerControls">
-  <documentManagement>
-    <_activity xmlns="4b64ee43-c309-4a11-a8e8-00d42015a2cd" xsi:nil="true"/>
-  </documentManagement>
-</p:properties>
-</file>
-
-<file path=customXml/item2.xml><?xml version="1.0" encoding="utf-8"?>
 <ct:contentTypeSchema xmlns:ct="http://schemas.microsoft.com/office/2006/metadata/contentType" xmlns:ma="http://schemas.microsoft.com/office/2006/metadata/properties/metaAttributes" ct:_="" ma:_="" ma:contentTypeName="Document" ma:contentTypeID="0x0101008534B1ABB2FD6E42B35F86D0A560EDF7" ma:contentTypeVersion="9" ma:contentTypeDescription="Create a new document." ma:contentTypeScope="" ma:versionID="3cfadc7b88e39a29fd7b22ab1819fb3a">
   <xsd:schema xmlns:xsd="http://www.w3.org/2001/XMLSchema" xmlns:xs="http://www.w3.org/2001/XMLSchema" xmlns:p="http://schemas.microsoft.com/office/2006/metadata/properties" xmlns:ns3="4b64ee43-c309-4a11-a8e8-00d42015a2cd" targetNamespace="http://schemas.microsoft.com/office/2006/metadata/properties" ma:root="true" ma:fieldsID="b0c00d69d8b3c6ce7e43758c32686041" ns3:_="">
     <xsd:import namespace="4b64ee43-c309-4a11-a8e8-00d42015a2cd"/>
@@ -33420,6 +34280,14 @@
 </ct:contentTypeSchema>
 </file>
 
+<file path=customXml/item2.xml><?xml version="1.0" encoding="utf-8"?>
+<p:properties xmlns:p="http://schemas.microsoft.com/office/2006/metadata/properties" xmlns:xsi="http://www.w3.org/2001/XMLSchema-instance" xmlns:pc="http://schemas.microsoft.com/office/infopath/2007/PartnerControls">
+  <documentManagement>
+    <_activity xmlns="4b64ee43-c309-4a11-a8e8-00d42015a2cd" xsi:nil="true"/>
+  </documentManagement>
+</p:properties>
+</file>
+
 <file path=customXml/item3.xml><?xml version="1.0" encoding="utf-8"?>
 <?mso-contentType ?>
 <FormTemplates xmlns="http://schemas.microsoft.com/sharepoint/v3/contenttype/forms">
@@ -33430,22 +34298,6 @@
 </file>
 
 <file path=customXml/itemProps1.xml><?xml version="1.0" encoding="utf-8"?>
-<ds:datastoreItem xmlns:ds="http://schemas.openxmlformats.org/officeDocument/2006/customXml" ds:itemID="{82B2CC27-3E32-47AF-AABF-86AD97E17D4A}">
-  <ds:schemaRefs>
-    <ds:schemaRef ds:uri="http://purl.org/dc/dcmitype/"/>
-    <ds:schemaRef ds:uri="http://schemas.openxmlformats.org/package/2006/metadata/core-properties"/>
-    <ds:schemaRef ds:uri="http://purl.org/dc/elements/1.1/"/>
-    <ds:schemaRef ds:uri="http://www.w3.org/XML/1998/namespace"/>
-    <ds:schemaRef ds:uri="http://purl.org/dc/terms/"/>
-    <ds:schemaRef ds:uri="http://schemas.microsoft.com/office/2006/documentManagement/types"/>
-    <ds:schemaRef ds:uri="http://schemas.microsoft.com/office/2006/metadata/properties"/>
-    <ds:schemaRef ds:uri="http://schemas.microsoft.com/office/infopath/2007/PartnerControls"/>
-    <ds:schemaRef ds:uri="4b64ee43-c309-4a11-a8e8-00d42015a2cd"/>
-  </ds:schemaRefs>
-</ds:datastoreItem>
-</file>
-
-<file path=customXml/itemProps2.xml><?xml version="1.0" encoding="utf-8"?>
 <ds:datastoreItem xmlns:ds="http://schemas.openxmlformats.org/officeDocument/2006/customXml" ds:itemID="{87D8C716-7C6B-40CE-92E4-2D83C09E9A52}">
   <ds:schemaRefs>
     <ds:schemaRef ds:uri="http://schemas.microsoft.com/office/2006/metadata/contentType"/>
@@ -33463,6 +34315,22 @@
 </ds:datastoreItem>
 </file>
 
+<file path=customXml/itemProps2.xml><?xml version="1.0" encoding="utf-8"?>
+<ds:datastoreItem xmlns:ds="http://schemas.openxmlformats.org/officeDocument/2006/customXml" ds:itemID="{82B2CC27-3E32-47AF-AABF-86AD97E17D4A}">
+  <ds:schemaRefs>
+    <ds:schemaRef ds:uri="http://purl.org/dc/dcmitype/"/>
+    <ds:schemaRef ds:uri="http://schemas.openxmlformats.org/package/2006/metadata/core-properties"/>
+    <ds:schemaRef ds:uri="http://purl.org/dc/elements/1.1/"/>
+    <ds:schemaRef ds:uri="http://www.w3.org/XML/1998/namespace"/>
+    <ds:schemaRef ds:uri="http://purl.org/dc/terms/"/>
+    <ds:schemaRef ds:uri="http://schemas.microsoft.com/office/2006/documentManagement/types"/>
+    <ds:schemaRef ds:uri="http://schemas.microsoft.com/office/2006/metadata/properties"/>
+    <ds:schemaRef ds:uri="http://schemas.microsoft.com/office/infopath/2007/PartnerControls"/>
+    <ds:schemaRef ds:uri="4b64ee43-c309-4a11-a8e8-00d42015a2cd"/>
+  </ds:schemaRefs>
+</ds:datastoreItem>
+</file>
+
 <file path=customXml/itemProps3.xml><?xml version="1.0" encoding="utf-8"?>
 <ds:datastoreItem xmlns:ds="http://schemas.openxmlformats.org/officeDocument/2006/customXml" ds:itemID="{512CCA92-3FFA-4B18-8825-6002805AEE9D}">
   <ds:schemaRefs>

</xml_diff>